<commit_message>
Remove tracked PowerPoint lock file and update deck
Stops tracking ~\$AML_Financial_Crime_Committee_Deck_v2.pptx (an Office lock
file that was committed by accident) and ignores ~\$* going forward.
</commit_message>
<xml_diff>
--- a/AML_Financial_Crime_Committee_Deck_v2.pptx
+++ b/AML_Financial_Crime_Committee_Deck_v2.pptx
@@ -4,15 +4,15 @@
   <p:sldMasterIdLst>
     <p:sldMasterId id="2147483648" r:id="rId1"/>
   </p:sldMasterIdLst>
+  <p:notesMasterIdLst>
+    <p:notesMasterId r:id="rId4"/>
+  </p:notesMasterIdLst>
   <p:sldIdLst>
     <p:sldId id="256" r:id="rId2"/>
     <p:sldId id="257" r:id="rId3"/>
   </p:sldIdLst>
-  <p:notesMasterIdLst>
-    <p:notesMasterId r:id="rId4"/>
-  </p:notesMasterIdLst>
-  <p:sldSz cx="12191695" cy="6858000"/>
-  <p:notesSz cx="6858000" cy="12191695"/>
+  <p:sldSz cx="12192000" cy="6858000"/>
+  <p:notesSz cx="6858000" cy="12192000"/>
   <p:defaultTextStyle>
     <a:lvl1pPr marL="0" algn="l" defTabSz="914400" rtl="0" eaLnBrk="1" latinLnBrk="0" hangingPunct="1">
       <a:defRPr sz="1800" kern="1200">
@@ -105,6 +105,11 @@
       </a:defRPr>
     </a:lvl9pPr>
   </p:defaultTextStyle>
+  <p:extLst>
+    <p:ext uri="{EFAFB233-063F-42B5-8137-9DF3F51BA10A}">
+      <p15:sldGuideLst xmlns:p15="http://schemas.microsoft.com/office/powerpoint/2012/main"/>
+    </p:ext>
+  </p:extLst>
 </p:presentation>
 </file>
 
@@ -130,234 +135,10 @@
           <a:chExt cx="0" cy="0"/>
         </a:xfrm>
       </p:grpSpPr>
-      <p:sp>
-        <p:nvSpPr>
-          <p:cNvPr id="2" name="Header Placeholder 1"/>
-          <p:cNvSpPr>
-            <a:spLocks noGrp="1"/>
-          </p:cNvSpPr>
-          <p:nvPr>
-            <p:ph type="hdr" sz="quarter"/>
-          </p:nvPr>
-        </p:nvSpPr>
-        <p:spPr>
-          <a:xfrm>
-            <a:off x="0" y="0"/>
-            <a:ext cx="2971800" cy="458788"/>
-          </a:xfrm>
-          <a:prstGeom prst="rect">
-            <a:avLst/>
-          </a:prstGeom>
-        </p:spPr>
-        <p:txBody>
-          <a:bodyPr vert="horz" lIns="91440" tIns="45720" rIns="91440" bIns="45720" rtlCol="0"/>
-          <a:lstStyle>
-            <a:lvl1pPr algn="l">
-              <a:defRPr sz="1200"/>
-            </a:lvl1pPr>
-          </a:lstStyle>
-          <a:p>
-            <a:endParaRPr lang="en-US"/>
-          </a:p>
-        </p:txBody>
-      </p:sp>
-      <p:sp>
-        <p:nvSpPr>
-          <p:cNvPr id="3" name="Date Placeholder 2"/>
-          <p:cNvSpPr>
-            <a:spLocks noGrp="1"/>
-          </p:cNvSpPr>
-          <p:nvPr>
-            <p:ph type="dt" idx="1"/>
-          </p:nvPr>
-        </p:nvSpPr>
-        <p:spPr>
-          <a:xfrm>
-            <a:off x="3884613" y="0"/>
-            <a:ext cx="2971800" cy="458788"/>
-          </a:xfrm>
-          <a:prstGeom prst="rect">
-            <a:avLst/>
-          </a:prstGeom>
-        </p:spPr>
-        <p:txBody>
-          <a:bodyPr vert="horz" lIns="91440" tIns="45720" rIns="91440" bIns="45720" rtlCol="0"/>
-          <a:lstStyle>
-            <a:lvl1pPr algn="r">
-              <a:defRPr sz="1200"/>
-            </a:lvl1pPr>
-          </a:lstStyle>
-          <a:p>
-            <a:fld id="{5282F153-3F37-0F45-9E97-73ACFA13230C}" type="datetimeFigureOut">
-              <a:rPr lang="en-US"/>
-              <a:t>7/23/19</a:t>
-            </a:fld>
-            <a:endParaRPr lang="en-US"/>
-          </a:p>
-        </p:txBody>
-      </p:sp>
-      <p:sp>
-        <p:nvSpPr>
-          <p:cNvPr id="4" name="Slide Image Placeholder 3"/>
-          <p:cNvSpPr>
-            <a:spLocks noGrp="1" noRot="1" noChangeAspect="1"/>
-          </p:cNvSpPr>
-          <p:nvPr>
-            <p:ph type="sldImg" idx="2"/>
-          </p:nvPr>
-        </p:nvSpPr>
-        <p:spPr>
-          <a:xfrm>
-            <a:off x="685800" y="1143000"/>
-            <a:ext cx="5486400" cy="3086100"/>
-          </a:xfrm>
-          <a:prstGeom prst="rect">
-            <a:avLst/>
-          </a:prstGeom>
-          <a:noFill/>
-          <a:ln w="12700">
-            <a:solidFill>
-              <a:prstClr val="black"/>
-            </a:solidFill>
-          </a:ln>
-        </p:spPr>
-        <p:txBody>
-          <a:bodyPr vert="horz" lIns="91440" tIns="45720" rIns="91440" bIns="45720" rtlCol="0" anchor="ctr"/>
-          <a:lstStyle/>
-          <a:p>
-            <a:endParaRPr lang="en-US"/>
-          </a:p>
-        </p:txBody>
-      </p:sp>
-      <p:sp>
-        <p:nvSpPr>
-          <p:cNvPr id="5" name="Notes Placeholder 4"/>
-          <p:cNvSpPr>
-            <a:spLocks noGrp="1"/>
-          </p:cNvSpPr>
-          <p:nvPr>
-            <p:ph type="body" sz="quarter" idx="3"/>
-          </p:nvPr>
-        </p:nvSpPr>
-        <p:spPr>
-          <a:xfrm>
-            <a:off x="685800" y="4400550"/>
-            <a:ext cx="5486400" cy="3600450"/>
-          </a:xfrm>
-          <a:prstGeom prst="rect">
-            <a:avLst/>
-          </a:prstGeom>
-        </p:spPr>
-        <p:txBody>
-          <a:bodyPr vert="horz" lIns="91440" tIns="45720" rIns="91440" bIns="45720" rtlCol="0"/>
-          <a:lstStyle/>
-          <a:p>
-            <a:pPr lvl="0"/>
-            <a:r>
-              <a:rPr lang="en-US"/>
-              <a:t>Click to edit Master text styles</a:t>
-            </a:r>
-          </a:p>
-          <a:p>
-            <a:pPr lvl="1"/>
-            <a:r>
-              <a:rPr lang="en-US"/>
-              <a:t>Second level</a:t>
-            </a:r>
-          </a:p>
-          <a:p>
-            <a:pPr lvl="2"/>
-            <a:r>
-              <a:rPr lang="en-US"/>
-              <a:t>Third level</a:t>
-            </a:r>
-          </a:p>
-          <a:p>
-            <a:pPr lvl="3"/>
-            <a:r>
-              <a:rPr lang="en-US"/>
-              <a:t>Fourth level</a:t>
-            </a:r>
-          </a:p>
-          <a:p>
-            <a:pPr lvl="4"/>
-            <a:r>
-              <a:rPr lang="en-US"/>
-              <a:t>Fifth level</a:t>
-            </a:r>
-          </a:p>
-        </p:txBody>
-      </p:sp>
-      <p:sp>
-        <p:nvSpPr>
-          <p:cNvPr id="6" name="Footer Placeholder 5"/>
-          <p:cNvSpPr>
-            <a:spLocks noGrp="1"/>
-          </p:cNvSpPr>
-          <p:nvPr>
-            <p:ph type="ftr" sz="quarter" idx="4"/>
-          </p:nvPr>
-        </p:nvSpPr>
-        <p:spPr>
-          <a:xfrm>
-            <a:off x="0" y="8685213"/>
-            <a:ext cx="2971800" cy="458787"/>
-          </a:xfrm>
-          <a:prstGeom prst="rect">
-            <a:avLst/>
-          </a:prstGeom>
-        </p:spPr>
-        <p:txBody>
-          <a:bodyPr vert="horz" lIns="91440" tIns="45720" rIns="91440" bIns="45720" rtlCol="0" anchor="b"/>
-          <a:lstStyle>
-            <a:lvl1pPr algn="l">
-              <a:defRPr sz="1200"/>
-            </a:lvl1pPr>
-          </a:lstStyle>
-          <a:p>
-            <a:endParaRPr lang="en-US"/>
-          </a:p>
-        </p:txBody>
-      </p:sp>
-      <p:sp>
-        <p:nvSpPr>
-          <p:cNvPr id="7" name="Slide Number Placeholder 6"/>
-          <p:cNvSpPr>
-            <a:spLocks noGrp="1"/>
-          </p:cNvSpPr>
-          <p:nvPr>
-            <p:ph type="sldNum" sz="quarter" idx="5"/>
-          </p:nvPr>
-        </p:nvSpPr>
-        <p:spPr>
-          <a:xfrm>
-            <a:off x="3884613" y="8685213"/>
-            <a:ext cx="2971800" cy="458787"/>
-          </a:xfrm>
-          <a:prstGeom prst="rect">
-            <a:avLst/>
-          </a:prstGeom>
-        </p:spPr>
-        <p:txBody>
-          <a:bodyPr vert="horz" lIns="91440" tIns="45720" rIns="91440" bIns="45720" rtlCol="0" anchor="b"/>
-          <a:lstStyle>
-            <a:lvl1pPr algn="r">
-              <a:defRPr sz="1200"/>
-            </a:lvl1pPr>
-          </a:lstStyle>
-          <a:p>
-            <a:fld id="{CE5E9CC1-C706-0F49-92D6-E571CC5EEA8F}" type="slidenum">
-              <a:rPr lang="en-US"/>
-              <a:t>‹#›</a:t>
-            </a:fld>
-            <a:endParaRPr lang="en-US"/>
-          </a:p>
-        </p:txBody>
-      </p:sp>
     </p:spTree>
     <p:extLst>
       <p:ext uri="{BB962C8B-B14F-4D97-AF65-F5344CB8AC3E}">
-        <p14:creationId xmlns:p14="http://schemas.microsoft.com/office/powerpoint/2010/main" val="1024086991"/>
+        <p14:creationId xmlns:p14="http://schemas.microsoft.com/office/powerpoint/2010/main" val="877450263"/>
       </p:ext>
     </p:extLst>
   </p:cSld>
@@ -501,10 +282,6 @@
           <a:bodyPr/>
           <a:lstStyle/>
           <a:p>
-            <a:r>
-              <a:rPr lang="en-US" dirty="0"/>
-              <a:t/>
-            </a:r>
             <a:endParaRPr lang="en-US" dirty="0"/>
           </a:p>
         </p:txBody>
@@ -589,10 +366,6 @@
           <a:bodyPr/>
           <a:lstStyle/>
           <a:p>
-            <a:r>
-              <a:rPr lang="en-US" dirty="0"/>
-              <a:t/>
-            </a:r>
             <a:endParaRPr lang="en-US" dirty="0"/>
           </a:p>
         </p:txBody>
@@ -666,6 +439,11 @@
 <file path=ppt/slideMasters/slideMaster1.xml><?xml version="1.0" encoding="utf-8"?>
 <p:sldMaster xmlns:a="http://schemas.openxmlformats.org/drawingml/2006/main" xmlns:r="http://schemas.openxmlformats.org/officeDocument/2006/relationships" xmlns:p="http://schemas.openxmlformats.org/presentationml/2006/main">
   <p:cSld>
+    <p:bg>
+      <p:bgRef idx="1001">
+        <a:schemeClr val="bg1"/>
+      </p:bgRef>
+    </p:bg>
     <p:spTree>
       <p:nvGrpSpPr>
         <p:cNvPr id="1" name=""/>
@@ -948,6 +726,7 @@
         <a:solidFill>
           <a:srgbClr val="17142B"/>
         </a:solidFill>
+        <a:effectLst/>
       </p:bgPr>
     </p:bg>
     <p:spTree>
@@ -985,11 +764,11 @@
           <a:bodyPr wrap="square" lIns="0" tIns="0" rIns="0" bIns="0" rtlCol="0" anchor="ctr"/>
           <a:lstStyle/>
           <a:p>
-            <a:pPr indent="0" marL="0">
+            <a:pPr marL="0" indent="0">
               <a:buNone/>
             </a:pPr>
             <a:r>
-              <a:rPr lang="en-US" sz="1100" b="1" spc="200" kern="0" dirty="0">
+              <a:rPr lang="en-US" sz="1100" b="1" kern="0" spc="200" dirty="0">
                 <a:solidFill>
                   <a:srgbClr val="C9C3F0"/>
                 </a:solidFill>
@@ -1024,7 +803,7 @@
           <a:bodyPr wrap="square" lIns="0" tIns="0" rIns="0" bIns="0" rtlCol="0" anchor="ctr"/>
           <a:lstStyle/>
           <a:p>
-            <a:pPr indent="0" marL="0">
+            <a:pPr marL="0" indent="0">
               <a:buNone/>
             </a:pPr>
             <a:r>
@@ -1063,7 +842,7 @@
           <a:bodyPr wrap="square" lIns="0" tIns="0" rIns="0" bIns="0" rtlCol="0" anchor="ctr"/>
           <a:lstStyle/>
           <a:p>
-            <a:pPr indent="0" marL="0">
+            <a:pPr marL="0" indent="0">
               <a:buNone/>
             </a:pPr>
             <a:r>
@@ -1103,14 +882,14 @@
       </p:sp>
       <p:pic>
         <p:nvPicPr>
-          <p:cNvPr id="6" name="Image 0" descr="C:\Users\avisy\AppData\Local\Temp\claude\C--Users-avisy-Downloads-Brainer-aml-crime-committee-agent\157c89c4-0a54-4ea8-9ae4-eefae4f561d0\scratchpad\deck\icon_lightbulb.png">    </p:cNvPr>
+          <p:cNvPr id="6" name="Image 0" descr="C:\Users\avisy\AppData\Local\Temp\claude\C--Users-avisy-Downloads-Brainer-aml-crime-committee-agent\157c89c4-0a54-4ea8-9ae4-eefae4f561d0\scratchpad\deck\icon_lightbulb.png"/>
           <p:cNvPicPr>
             <a:picLocks noChangeAspect="1"/>
           </p:cNvPicPr>
           <p:nvPr/>
         </p:nvPicPr>
         <p:blipFill>
-          <a:blip r:embed="rId1"/>
+          <a:blip r:embed="rId3"/>
           <a:stretch>
             <a:fillRect/>
           </a:stretch>
@@ -1146,11 +925,11 @@
           <a:bodyPr wrap="square" lIns="0" tIns="0" rIns="0" bIns="0" rtlCol="0" anchor="ctr"/>
           <a:lstStyle/>
           <a:p>
-            <a:pPr indent="0" marL="0">
+            <a:pPr marL="0" indent="0">
               <a:buNone/>
             </a:pPr>
             <a:r>
-              <a:rPr lang="en-US" sz="1600" b="1" spc="80" kern="0" dirty="0">
+              <a:rPr lang="en-US" sz="1600" b="1" kern="0" spc="80" dirty="0">
                 <a:solidFill>
                   <a:srgbClr val="FFFFFF"/>
                 </a:solidFill>
@@ -1185,7 +964,7 @@
           <a:bodyPr wrap="square" lIns="0" tIns="0" rIns="0" bIns="0" rtlCol="0" anchor="t"/>
           <a:lstStyle/>
           <a:p>
-            <a:pPr indent="0" marL="0">
+            <a:pPr marL="0" indent="0">
               <a:lnSpc>
                 <a:spcPct val="118000"/>
               </a:lnSpc>
@@ -1214,7 +993,7 @@
         </p:nvSpPr>
         <p:spPr>
           <a:xfrm>
-            <a:off x="548640" y="4023360"/>
+            <a:off x="548640" y="3351276"/>
             <a:ext cx="384048" cy="384048"/>
           </a:xfrm>
           <a:prstGeom prst="ellipse">
@@ -1228,21 +1007,21 @@
       </p:sp>
       <p:pic>
         <p:nvPicPr>
-          <p:cNvPr id="10" name="Image 1" descr="C:\Users\avisy\AppData\Local\Temp\claude\C--Users-avisy-Downloads-Brainer-aml-crime-committee-agent\157c89c4-0a54-4ea8-9ae4-eefae4f561d0\scratchpad\deck\icon_sitemap.png">    </p:cNvPr>
+          <p:cNvPr id="10" name="Image 1" descr="C:\Users\avisy\AppData\Local\Temp\claude\C--Users-avisy-Downloads-Brainer-aml-crime-committee-agent\157c89c4-0a54-4ea8-9ae4-eefae4f561d0\scratchpad\deck\icon_sitemap.png"/>
           <p:cNvPicPr>
             <a:picLocks noChangeAspect="1"/>
           </p:cNvPicPr>
           <p:nvPr/>
         </p:nvPicPr>
         <p:blipFill>
-          <a:blip r:embed="rId2"/>
+          <a:blip r:embed="rId4"/>
           <a:stretch>
             <a:fillRect/>
           </a:stretch>
         </p:blipFill>
         <p:spPr>
           <a:xfrm>
-            <a:off x="635051" y="4109771"/>
+            <a:off x="635051" y="3437687"/>
             <a:ext cx="211226" cy="211226"/>
           </a:xfrm>
           <a:prstGeom prst="rect">
@@ -1258,7 +1037,7 @@
         </p:nvSpPr>
         <p:spPr>
           <a:xfrm>
-            <a:off x="1097280" y="3986784"/>
+            <a:off x="1097280" y="3351276"/>
             <a:ext cx="10515600" cy="457200"/>
           </a:xfrm>
           <a:prstGeom prst="rect">
@@ -1271,11 +1050,11 @@
           <a:bodyPr wrap="square" lIns="0" tIns="0" rIns="0" bIns="0" rtlCol="0" anchor="ctr"/>
           <a:lstStyle/>
           <a:p>
-            <a:pPr indent="0" marL="0">
+            <a:pPr marL="0" indent="0">
               <a:buNone/>
             </a:pPr>
             <a:r>
-              <a:rPr lang="en-US" sz="1600" b="1" spc="80" kern="0" dirty="0">
+              <a:rPr lang="en-US" sz="1600" b="1" kern="0" spc="80" dirty="0">
                 <a:solidFill>
                   <a:srgbClr val="FFFFFF"/>
                 </a:solidFill>
@@ -1310,66 +1089,47 @@
           <a:bodyPr wrap="square" lIns="0" tIns="0" rIns="0" bIns="0" rtlCol="0" anchor="t"/>
           <a:lstStyle/>
           <a:p>
-            <a:pPr indent="0" marL="0">
+            <a:pPr marL="0" indent="0">
               <a:lnSpc>
                 <a:spcPct val="118000"/>
               </a:lnSpc>
               <a:buNone/>
             </a:pPr>
-            <a:r>
-              <a:rPr lang="en-US" sz="1250" dirty="0">
-                <a:solidFill>
-                  <a:srgbClr val="E4E1F5"/>
-                </a:solidFill>
-                <a:latin typeface="Calibri" pitchFamily="34" charset="0"/>
-                <a:ea typeface="Calibri" pitchFamily="34" charset="-122"/>
-                <a:cs typeface="Calibri" pitchFamily="34" charset="-120"/>
-              </a:rPr>
-              <a:t>The agent coordinates the five capabilities specified in the brief. A Query Understanding layer, backed by a Groq-hosted Llama 3.3 70B model with a deterministic rule-based fallback, extracts intent, filters, entities, and pattern type; a Dynamic Execution Planner turns that into an ordered tool-call plan. From there the agent selectively invokes an EDA Tool for exploratory profiling, a Feature Engineering Tool that computes velocity, rolling sums, amount deviation, and rapid cash-out ratios on demand, and an Anomaly Detection layer blending Benford's Law forensic accounting, threshold clustering, an Isolation Forest ML model, and network-graph centrality. A Risk Classification Tool converts these signals into a weighted composite score, and a four-agent Committee (Transaction Monitoring, KYC/UBO, Sanctions/PEP, Network Relationship) deliberates independently before a Chair Agent synthesizes a final, explainable escalation decision.</a:t>
-            </a:r>
             <a:endParaRPr lang="en-US" sz="1250" dirty="0"/>
           </a:p>
         </p:txBody>
       </p:sp>
-      <p:sp>
-        <p:nvSpPr>
-          <p:cNvPr id="13" name="Text 9"/>
-          <p:cNvSpPr/>
-          <p:nvPr/>
-        </p:nvSpPr>
-        <p:spPr>
-          <a:xfrm>
-            <a:off x="548640" y="6446520"/>
-            <a:ext cx="11064240" cy="274320"/>
+      <p:pic>
+        <p:nvPicPr>
+          <p:cNvPr id="16" name="Picture 15">
+            <a:extLst>
+              <a:ext uri="{FF2B5EF4-FFF2-40B4-BE49-F238E27FC236}">
+                <a16:creationId xmlns:a16="http://schemas.microsoft.com/office/drawing/2014/main" id="{30CFD4D8-1A58-AE20-B1AE-109AE8BDA578}"/>
+              </a:ext>
+            </a:extLst>
+          </p:cNvPr>
+          <p:cNvPicPr>
+            <a:picLocks noChangeAspect="1"/>
+          </p:cNvPicPr>
+          <p:nvPr/>
+        </p:nvPicPr>
+        <p:blipFill>
+          <a:blip r:embed="rId5"/>
+          <a:srcRect t="24534" b="9856"/>
+          <a:stretch>
+            <a:fillRect/>
+          </a:stretch>
+        </p:blipFill>
+        <p:spPr>
+          <a:xfrm>
+            <a:off x="-253440" y="3719835"/>
+            <a:ext cx="12698880" cy="2958084"/>
           </a:xfrm>
           <a:prstGeom prst="rect">
             <a:avLst/>
           </a:prstGeom>
-          <a:noFill/>
-          <a:ln/>
-        </p:spPr>
-        <p:txBody>
-          <a:bodyPr wrap="square" lIns="0" tIns="0" rIns="0" bIns="0" rtlCol="0" anchor="ctr"/>
-          <a:lstStyle/>
-          <a:p>
-            <a:pPr algn="ctr" indent="0" marL="0">
-              <a:buNone/>
-            </a:pPr>
-            <a:r>
-              <a:rPr lang="en-US" sz="1000" dirty="0">
-                <a:solidFill>
-                  <a:srgbClr val="9A93C9"/>
-                </a:solidFill>
-                <a:latin typeface="Calibri" pitchFamily="34" charset="0"/>
-                <a:ea typeface="Calibri" pitchFamily="34" charset="-122"/>
-                <a:cs typeface="Calibri" pitchFamily="34" charset="-120"/>
-              </a:rPr>
-              <a:t>Python  |  FastAPI  |  pandas / scikit-learn / networkx / scipy  |  Groq Llama 3.3 70B  |  Kaggle SAML-D dataset (9.5M transactions / 855K accounts)</a:t>
-            </a:r>
-            <a:endParaRPr lang="en-US" sz="1000" dirty="0"/>
-          </a:p>
-        </p:txBody>
-      </p:sp>
+        </p:spPr>
+      </p:pic>
     </p:spTree>
   </p:cSld>
   <p:clrMapOvr>
@@ -1386,6 +1146,7 @@
         <a:solidFill>
           <a:srgbClr val="F6F5FB"/>
         </a:solidFill>
+        <a:effectLst/>
       </p:bgPr>
     </p:bg>
     <p:spTree>
@@ -1423,7 +1184,7 @@
           <a:bodyPr wrap="square" lIns="0" tIns="0" rIns="0" bIns="0" rtlCol="0" anchor="ctr"/>
           <a:lstStyle/>
           <a:p>
-            <a:pPr indent="0" marL="0">
+            <a:pPr marL="0" indent="0">
               <a:buNone/>
             </a:pPr>
             <a:r>
@@ -1449,7 +1210,7 @@
         </p:nvSpPr>
         <p:spPr>
           <a:xfrm>
-            <a:off x="548640" y="960120"/>
+            <a:off x="548640" y="815122"/>
             <a:ext cx="384048" cy="384048"/>
           </a:xfrm>
           <a:prstGeom prst="ellipse">
@@ -1463,21 +1224,21 @@
       </p:sp>
       <p:pic>
         <p:nvPicPr>
-          <p:cNvPr id="4" name="Image 0" descr="C:\Users\avisy\AppData\Local\Temp\claude\C--Users-avisy-Downloads-Brainer-aml-crime-committee-agent\157c89c4-0a54-4ea8-9ae4-eefae4f561d0\scratchpad\deck\icon_cogs.png">    </p:cNvPr>
+          <p:cNvPr id="4" name="Image 0" descr="C:\Users\avisy\AppData\Local\Temp\claude\C--Users-avisy-Downloads-Brainer-aml-crime-committee-agent\157c89c4-0a54-4ea8-9ae4-eefae4f561d0\scratchpad\deck\icon_cogs.png"/>
           <p:cNvPicPr>
             <a:picLocks noChangeAspect="1"/>
           </p:cNvPicPr>
           <p:nvPr/>
         </p:nvPicPr>
         <p:blipFill>
-          <a:blip r:embed="rId1"/>
+          <a:blip r:embed="rId3"/>
           <a:stretch>
             <a:fillRect/>
           </a:stretch>
         </p:blipFill>
         <p:spPr>
           <a:xfrm>
-            <a:off x="635051" y="1046531"/>
+            <a:off x="635051" y="901533"/>
             <a:ext cx="211226" cy="211226"/>
           </a:xfrm>
           <a:prstGeom prst="rect">
@@ -1493,7 +1254,7 @@
         </p:nvSpPr>
         <p:spPr>
           <a:xfrm>
-            <a:off x="1097280" y="923544"/>
+            <a:off x="1097280" y="785451"/>
             <a:ext cx="10515600" cy="457200"/>
           </a:xfrm>
           <a:prstGeom prst="rect">
@@ -1506,11 +1267,11 @@
           <a:bodyPr wrap="square" lIns="0" tIns="0" rIns="0" bIns="0" rtlCol="0" anchor="ctr"/>
           <a:lstStyle/>
           <a:p>
-            <a:pPr indent="0" marL="0">
+            <a:pPr marL="0" indent="0">
               <a:buNone/>
             </a:pPr>
             <a:r>
-              <a:rPr lang="en-US" sz="1600" b="1" spc="80" kern="0" dirty="0">
+              <a:rPr lang="en-US" sz="1600" b="1" kern="0" spc="80" dirty="0">
                 <a:solidFill>
                   <a:srgbClr val="201C3A"/>
                 </a:solidFill>
@@ -1532,8 +1293,8 @@
         </p:nvSpPr>
         <p:spPr>
           <a:xfrm>
-            <a:off x="548640" y="1444752"/>
-            <a:ext cx="11064240" cy="2331720"/>
+            <a:off x="548640" y="1242651"/>
+            <a:ext cx="6598609" cy="2331720"/>
           </a:xfrm>
           <a:prstGeom prst="rect">
             <a:avLst/>
@@ -1545,24 +1306,21 @@
           <a:bodyPr wrap="square" lIns="0" tIns="0" rIns="0" bIns="0" rtlCol="0" anchor="t"/>
           <a:lstStyle/>
           <a:p>
-            <a:pPr indent="0" marL="0">
+            <a:pPr marL="0" indent="0">
               <a:lnSpc>
                 <a:spcPct val="116000"/>
               </a:lnSpc>
               <a:buNone/>
             </a:pPr>
             <a:r>
-              <a:rPr lang="en-US" sz="1200" dirty="0">
-                <a:solidFill>
-                  <a:srgbClr val="746F92"/>
-                </a:solidFill>
+              <a:rPr lang="en-US" sz="1200" b="1" dirty="0">
                 <a:latin typeface="Calibri" pitchFamily="34" charset="0"/>
                 <a:ea typeface="Calibri" pitchFamily="34" charset="-122"/>
                 <a:cs typeface="Calibri" pitchFamily="34" charset="-120"/>
               </a:rPr>
               <a:t>Risk scoring is a transparent weighted composite: Benford's Law deviation contributes 30%, threshold and round-number clustering 25%, the Isolation Forest ML anomaly score 25%, and network betweenness centrality 20%, and these weights rebalance automatically when a signal genuinely cannot be computed, such as when an account has too few transactions for Benford's Law to be statistically meaningful. Feature engineering computes transaction velocity, 30-day rolling sums, amount-deviation z-scores, sub-threshold counts, structuring-regularity scores, and rapid cash-out ratios, all vectorized with pandas so the pipeline stays responsive across the full dataset rather than looping per customer. Network analysis builds a directed transaction graph, computes betweenness centrality and Louvain community detection, and only flags an account when a real absolute signal, meaningful centrality or an actual connected flagged account, backs the designation rather than a relative statistical ranking alone. Explanations and committee reasoning come from the same Llama 3.3 70B model, with every numeric claim cross-checked against the real computed signals before it is trusted, and a deterministic template fallback whenever the API is unavailable.</a:t>
             </a:r>
-            <a:endParaRPr lang="en-US" sz="1200" dirty="0"/>
+            <a:endParaRPr lang="en-US" sz="1200" b="1" dirty="0"/>
           </a:p>
         </p:txBody>
       </p:sp>
@@ -1588,14 +1346,14 @@
       </p:sp>
       <p:pic>
         <p:nvPicPr>
-          <p:cNvPr id="8" name="Image 1" descr="C:\Users\avisy\AppData\Local\Temp\claude\C--Users-avisy-Downloads-Brainer-aml-crime-committee-agent\157c89c4-0a54-4ea8-9ae4-eefae4f561d0\scratchpad\deck\icon_trophy.png">    </p:cNvPr>
+          <p:cNvPr id="8" name="Image 1" descr="C:\Users\avisy\AppData\Local\Temp\claude\C--Users-avisy-Downloads-Brainer-aml-crime-committee-agent\157c89c4-0a54-4ea8-9ae4-eefae4f561d0\scratchpad\deck\icon_trophy.png"/>
           <p:cNvPicPr>
             <a:picLocks noChangeAspect="1"/>
           </p:cNvPicPr>
           <p:nvPr/>
         </p:nvPicPr>
         <p:blipFill>
-          <a:blip r:embed="rId2"/>
+          <a:blip r:embed="rId4"/>
           <a:stretch>
             <a:fillRect/>
           </a:stretch>
@@ -1631,11 +1389,11 @@
           <a:bodyPr wrap="square" lIns="0" tIns="0" rIns="0" bIns="0" rtlCol="0" anchor="ctr"/>
           <a:lstStyle/>
           <a:p>
-            <a:pPr indent="0" marL="0">
+            <a:pPr marL="0" indent="0">
               <a:buNone/>
             </a:pPr>
             <a:r>
-              <a:rPr lang="en-US" sz="1600" b="1" spc="80" kern="0" dirty="0">
+              <a:rPr lang="en-US" sz="1600" b="1" kern="0" spc="80" dirty="0">
                 <a:solidFill>
                   <a:srgbClr val="6D5EF7"/>
                 </a:solidFill>
@@ -1657,8 +1415,8 @@
         </p:nvSpPr>
         <p:spPr>
           <a:xfrm>
-            <a:off x="548640" y="4462272"/>
-            <a:ext cx="11064240" cy="1874520"/>
+            <a:off x="3825550" y="4462272"/>
+            <a:ext cx="7787329" cy="1874520"/>
           </a:xfrm>
           <a:prstGeom prst="rect">
             <a:avLst/>
@@ -1670,14 +1428,14 @@
           <a:bodyPr wrap="square" lIns="0" tIns="0" rIns="0" bIns="0" rtlCol="0" anchor="t"/>
           <a:lstStyle/>
           <a:p>
-            <a:pPr indent="0" marL="0">
+            <a:pPr marL="0" indent="0">
               <a:lnSpc>
                 <a:spcPct val="116000"/>
               </a:lnSpc>
               <a:buNone/>
             </a:pPr>
             <a:r>
-              <a:rPr lang="en-US" sz="1200" dirty="0">
+              <a:rPr lang="en-US" sz="1200" b="1" dirty="0">
                 <a:solidFill>
                   <a:srgbClr val="201C3A"/>
                 </a:solidFill>
@@ -1687,7 +1445,7 @@
               </a:rPr>
               <a:t>Unlike most hackathon submissions, this system runs against the real, full-scale Kaggle SAML-D dataset, 9.5 million transactions across 855,000 accounts, not a small synthetic sample, and every tool was engineered to stay responsive at that scale. The agent's adaptiveness is not just claimed but provable: a Preview Plan endpoint shows exactly which tools a specific query will invoke before it runs, so a judge can verify the dynamic planning directly. Where most anomaly-detection demos rely purely on a black-box ML score, this one adds real forensic-accounting rigor with statistical safeguards against small-sample false positives. The four-specialist Committee produces genuine deliberation rather than a single opaque number, and when the quantitative risk score and the committee's qualitative decision disagree, the Chair explicitly states why instead of leaving the contradiction unexplained. Judges can also upload their own CSV to replace the live dataset, and every output panel, the banner, the Risk Memo, and the Committee Minutes, is guaranteed to cite the same case ID and the same underlying signals.</a:t>
             </a:r>
-            <a:endParaRPr lang="en-US" sz="1200" dirty="0"/>
+            <a:endParaRPr lang="en-US" sz="1200" b="1" dirty="0"/>
           </a:p>
         </p:txBody>
       </p:sp>
@@ -1699,7 +1457,7 @@
         </p:nvSpPr>
         <p:spPr>
           <a:xfrm>
-            <a:off x="548640" y="6446520"/>
+            <a:off x="548640" y="6583680"/>
             <a:ext cx="11064240" cy="274320"/>
           </a:xfrm>
           <a:prstGeom prst="rect">
@@ -1712,7 +1470,7 @@
           <a:bodyPr wrap="square" lIns="0" tIns="0" rIns="0" bIns="0" rtlCol="0" anchor="ctr"/>
           <a:lstStyle/>
           <a:p>
-            <a:pPr algn="ctr" indent="0" marL="0">
+            <a:pPr marL="0" indent="0" algn="ctr">
               <a:buNone/>
             </a:pPr>
             <a:r>
@@ -1730,6 +1488,37 @@
           </a:p>
         </p:txBody>
       </p:sp>
+      <p:pic>
+        <p:nvPicPr>
+          <p:cNvPr id="12" name="Picture 11">
+            <a:extLst>
+              <a:ext uri="{FF2B5EF4-FFF2-40B4-BE49-F238E27FC236}">
+                <a16:creationId xmlns:a16="http://schemas.microsoft.com/office/drawing/2014/main" id="{0E0C9818-889C-C5A1-3773-BB22C5DFAF56}"/>
+              </a:ext>
+            </a:extLst>
+          </p:cNvPr>
+          <p:cNvPicPr>
+            <a:picLocks noChangeAspect="1"/>
+          </p:cNvPicPr>
+          <p:nvPr/>
+        </p:nvPicPr>
+        <p:blipFill>
+          <a:blip r:embed="rId5"/>
+          <a:srcRect b="7099"/>
+          <a:stretch>
+            <a:fillRect/>
+          </a:stretch>
+        </p:blipFill>
+        <p:spPr>
+          <a:xfrm>
+            <a:off x="7147249" y="563522"/>
+            <a:ext cx="4721290" cy="3377542"/>
+          </a:xfrm>
+          <a:prstGeom prst="rect">
+            <a:avLst/>
+          </a:prstGeom>
+        </p:spPr>
+      </p:pic>
     </p:spTree>
   </p:cSld>
   <p:clrMapOvr>
@@ -2031,4 +1820,299 @@
     </a:ext>
   </a:extLst>
 </a:theme>
+</file>
+
+<file path=ppt/theme/theme2.xml><?xml version="1.0" encoding="utf-8"?>
+<a:theme xmlns:a="http://schemas.openxmlformats.org/drawingml/2006/main" name="Office Theme">
+  <a:themeElements>
+    <a:clrScheme name="Office">
+      <a:dk1>
+        <a:sysClr val="windowText" lastClr="000000"/>
+      </a:dk1>
+      <a:lt1>
+        <a:sysClr val="window" lastClr="FFFFFF"/>
+      </a:lt1>
+      <a:dk2>
+        <a:srgbClr val="44546A"/>
+      </a:dk2>
+      <a:lt2>
+        <a:srgbClr val="E7E6E6"/>
+      </a:lt2>
+      <a:accent1>
+        <a:srgbClr val="4472C4"/>
+      </a:accent1>
+      <a:accent2>
+        <a:srgbClr val="ED7D31"/>
+      </a:accent2>
+      <a:accent3>
+        <a:srgbClr val="A5A5A5"/>
+      </a:accent3>
+      <a:accent4>
+        <a:srgbClr val="FFC000"/>
+      </a:accent4>
+      <a:accent5>
+        <a:srgbClr val="5B9BD5"/>
+      </a:accent5>
+      <a:accent6>
+        <a:srgbClr val="70AD47"/>
+      </a:accent6>
+      <a:hlink>
+        <a:srgbClr val="0563C1"/>
+      </a:hlink>
+      <a:folHlink>
+        <a:srgbClr val="954F72"/>
+      </a:folHlink>
+    </a:clrScheme>
+    <a:fontScheme name="Office">
+      <a:majorFont>
+        <a:latin typeface="Calibri Light" panose="020F0302020204030204"/>
+        <a:ea typeface=""/>
+        <a:cs typeface=""/>
+        <a:font script="Jpan" typeface="游ゴシック Light"/>
+        <a:font script="Hang" typeface="맑은 고딕"/>
+        <a:font script="Hans" typeface="等线 Light"/>
+        <a:font script="Hant" typeface="新細明體"/>
+        <a:font script="Arab" typeface="Times New Roman"/>
+        <a:font script="Hebr" typeface="Times New Roman"/>
+        <a:font script="Thai" typeface="Angsana New"/>
+        <a:font script="Ethi" typeface="Nyala"/>
+        <a:font script="Beng" typeface="Vrinda"/>
+        <a:font script="Gujr" typeface="Shruti"/>
+        <a:font script="Khmr" typeface="MoolBoran"/>
+        <a:font script="Knda" typeface="Tunga"/>
+        <a:font script="Guru" typeface="Raavi"/>
+        <a:font script="Cans" typeface="Euphemia"/>
+        <a:font script="Cher" typeface="Plantagenet Cherokee"/>
+        <a:font script="Yiii" typeface="Microsoft Yi Baiti"/>
+        <a:font script="Tibt" typeface="Microsoft Himalaya"/>
+        <a:font script="Thaa" typeface="MV Boli"/>
+        <a:font script="Deva" typeface="Mangal"/>
+        <a:font script="Telu" typeface="Gautami"/>
+        <a:font script="Taml" typeface="Latha"/>
+        <a:font script="Syrc" typeface="Estrangelo Edessa"/>
+        <a:font script="Orya" typeface="Kalinga"/>
+        <a:font script="Mlym" typeface="Kartika"/>
+        <a:font script="Laoo" typeface="DokChampa"/>
+        <a:font script="Sinh" typeface="Iskoola Pota"/>
+        <a:font script="Mong" typeface="Mongolian Baiti"/>
+        <a:font script="Viet" typeface="Times New Roman"/>
+        <a:font script="Uigh" typeface="Microsoft Uighur"/>
+        <a:font script="Geor" typeface="Sylfaen"/>
+        <a:font script="Armn" typeface="Arial"/>
+        <a:font script="Bugi" typeface="Leelawadee UI"/>
+        <a:font script="Bopo" typeface="Microsoft JhengHei"/>
+        <a:font script="Java" typeface="Javanese Text"/>
+        <a:font script="Lisu" typeface="Segoe UI"/>
+        <a:font script="Mymr" typeface="Myanmar Text"/>
+        <a:font script="Nkoo" typeface="Ebrima"/>
+        <a:font script="Olck" typeface="Nirmala UI"/>
+        <a:font script="Osma" typeface="Ebrima"/>
+        <a:font script="Phag" typeface="Phagspa"/>
+        <a:font script="Syrn" typeface="Estrangelo Edessa"/>
+        <a:font script="Syrj" typeface="Estrangelo Edessa"/>
+        <a:font script="Syre" typeface="Estrangelo Edessa"/>
+        <a:font script="Sora" typeface="Nirmala UI"/>
+        <a:font script="Tale" typeface="Microsoft Tai Le"/>
+        <a:font script="Talu" typeface="Microsoft New Tai Lue"/>
+        <a:font script="Tfng" typeface="Ebrima"/>
+      </a:majorFont>
+      <a:minorFont>
+        <a:latin typeface="Calibri" panose="020F0502020204030204"/>
+        <a:ea typeface=""/>
+        <a:cs typeface=""/>
+        <a:font script="Jpan" typeface="游ゴシック"/>
+        <a:font script="Hang" typeface="맑은 고딕"/>
+        <a:font script="Hans" typeface="等线"/>
+        <a:font script="Hant" typeface="新細明體"/>
+        <a:font script="Arab" typeface="Arial"/>
+        <a:font script="Hebr" typeface="Arial"/>
+        <a:font script="Thai" typeface="Cordia New"/>
+        <a:font script="Ethi" typeface="Nyala"/>
+        <a:font script="Beng" typeface="Vrinda"/>
+        <a:font script="Gujr" typeface="Shruti"/>
+        <a:font script="Khmr" typeface="DaunPenh"/>
+        <a:font script="Knda" typeface="Tunga"/>
+        <a:font script="Guru" typeface="Raavi"/>
+        <a:font script="Cans" typeface="Euphemia"/>
+        <a:font script="Cher" typeface="Plantagenet Cherokee"/>
+        <a:font script="Yiii" typeface="Microsoft Yi Baiti"/>
+        <a:font script="Tibt" typeface="Microsoft Himalaya"/>
+        <a:font script="Thaa" typeface="MV Boli"/>
+        <a:font script="Deva" typeface="Mangal"/>
+        <a:font script="Telu" typeface="Gautami"/>
+        <a:font script="Taml" typeface="Latha"/>
+        <a:font script="Syrc" typeface="Estrangelo Edessa"/>
+        <a:font script="Orya" typeface="Kalinga"/>
+        <a:font script="Mlym" typeface="Kartika"/>
+        <a:font script="Laoo" typeface="DokChampa"/>
+        <a:font script="Sinh" typeface="Iskoola Pota"/>
+        <a:font script="Mong" typeface="Mongolian Baiti"/>
+        <a:font script="Viet" typeface="Arial"/>
+        <a:font script="Uigh" typeface="Microsoft Uighur"/>
+        <a:font script="Geor" typeface="Sylfaen"/>
+        <a:font script="Armn" typeface="Arial"/>
+        <a:font script="Bugi" typeface="Leelawadee UI"/>
+        <a:font script="Bopo" typeface="Microsoft JhengHei"/>
+        <a:font script="Java" typeface="Javanese Text"/>
+        <a:font script="Lisu" typeface="Segoe UI"/>
+        <a:font script="Mymr" typeface="Myanmar Text"/>
+        <a:font script="Nkoo" typeface="Ebrima"/>
+        <a:font script="Olck" typeface="Nirmala UI"/>
+        <a:font script="Osma" typeface="Ebrima"/>
+        <a:font script="Phag" typeface="Phagspa"/>
+        <a:font script="Syrn" typeface="Estrangelo Edessa"/>
+        <a:font script="Syrj" typeface="Estrangelo Edessa"/>
+        <a:font script="Syre" typeface="Estrangelo Edessa"/>
+        <a:font script="Sora" typeface="Nirmala UI"/>
+        <a:font script="Tale" typeface="Microsoft Tai Le"/>
+        <a:font script="Talu" typeface="Microsoft New Tai Lue"/>
+        <a:font script="Tfng" typeface="Ebrima"/>
+      </a:minorFont>
+    </a:fontScheme>
+    <a:fmtScheme name="Office">
+      <a:fillStyleLst>
+        <a:solidFill>
+          <a:schemeClr val="phClr"/>
+        </a:solidFill>
+        <a:gradFill rotWithShape="1">
+          <a:gsLst>
+            <a:gs pos="0">
+              <a:schemeClr val="phClr">
+                <a:lumMod val="110000"/>
+                <a:satMod val="105000"/>
+                <a:tint val="67000"/>
+              </a:schemeClr>
+            </a:gs>
+            <a:gs pos="50000">
+              <a:schemeClr val="phClr">
+                <a:lumMod val="105000"/>
+                <a:satMod val="103000"/>
+                <a:tint val="73000"/>
+              </a:schemeClr>
+            </a:gs>
+            <a:gs pos="100000">
+              <a:schemeClr val="phClr">
+                <a:lumMod val="105000"/>
+                <a:satMod val="109000"/>
+                <a:tint val="81000"/>
+              </a:schemeClr>
+            </a:gs>
+          </a:gsLst>
+          <a:lin ang="5400000" scaled="0"/>
+        </a:gradFill>
+        <a:gradFill rotWithShape="1">
+          <a:gsLst>
+            <a:gs pos="0">
+              <a:schemeClr val="phClr">
+                <a:satMod val="103000"/>
+                <a:lumMod val="102000"/>
+                <a:tint val="94000"/>
+              </a:schemeClr>
+            </a:gs>
+            <a:gs pos="50000">
+              <a:schemeClr val="phClr">
+                <a:satMod val="110000"/>
+                <a:lumMod val="100000"/>
+                <a:shade val="100000"/>
+              </a:schemeClr>
+            </a:gs>
+            <a:gs pos="100000">
+              <a:schemeClr val="phClr">
+                <a:lumMod val="99000"/>
+                <a:satMod val="120000"/>
+                <a:shade val="78000"/>
+              </a:schemeClr>
+            </a:gs>
+          </a:gsLst>
+          <a:lin ang="5400000" scaled="0"/>
+        </a:gradFill>
+      </a:fillStyleLst>
+      <a:lnStyleLst>
+        <a:ln w="6350" cap="flat" cmpd="sng" algn="ctr">
+          <a:solidFill>
+            <a:schemeClr val="phClr"/>
+          </a:solidFill>
+          <a:prstDash val="solid"/>
+          <a:miter lim="800000"/>
+        </a:ln>
+        <a:ln w="12700" cap="flat" cmpd="sng" algn="ctr">
+          <a:solidFill>
+            <a:schemeClr val="phClr"/>
+          </a:solidFill>
+          <a:prstDash val="solid"/>
+          <a:miter lim="800000"/>
+        </a:ln>
+        <a:ln w="19050" cap="flat" cmpd="sng" algn="ctr">
+          <a:solidFill>
+            <a:schemeClr val="phClr"/>
+          </a:solidFill>
+          <a:prstDash val="solid"/>
+          <a:miter lim="800000"/>
+        </a:ln>
+      </a:lnStyleLst>
+      <a:effectStyleLst>
+        <a:effectStyle>
+          <a:effectLst/>
+        </a:effectStyle>
+        <a:effectStyle>
+          <a:effectLst/>
+        </a:effectStyle>
+        <a:effectStyle>
+          <a:effectLst>
+            <a:outerShdw blurRad="57150" dist="19050" dir="5400000" algn="ctr" rotWithShape="0">
+              <a:srgbClr val="000000">
+                <a:alpha val="63000"/>
+              </a:srgbClr>
+            </a:outerShdw>
+          </a:effectLst>
+        </a:effectStyle>
+      </a:effectStyleLst>
+      <a:bgFillStyleLst>
+        <a:solidFill>
+          <a:schemeClr val="phClr"/>
+        </a:solidFill>
+        <a:solidFill>
+          <a:schemeClr val="phClr">
+            <a:tint val="95000"/>
+            <a:satMod val="170000"/>
+          </a:schemeClr>
+        </a:solidFill>
+        <a:gradFill rotWithShape="1">
+          <a:gsLst>
+            <a:gs pos="0">
+              <a:schemeClr val="phClr">
+                <a:tint val="93000"/>
+                <a:satMod val="150000"/>
+                <a:shade val="98000"/>
+                <a:lumMod val="102000"/>
+              </a:schemeClr>
+            </a:gs>
+            <a:gs pos="50000">
+              <a:schemeClr val="phClr">
+                <a:tint val="98000"/>
+                <a:satMod val="130000"/>
+                <a:shade val="90000"/>
+                <a:lumMod val="103000"/>
+              </a:schemeClr>
+            </a:gs>
+            <a:gs pos="100000">
+              <a:schemeClr val="phClr">
+                <a:shade val="63000"/>
+                <a:satMod val="120000"/>
+              </a:schemeClr>
+            </a:gs>
+          </a:gsLst>
+          <a:lin ang="5400000" scaled="0"/>
+        </a:gradFill>
+      </a:bgFillStyleLst>
+    </a:fmtScheme>
+  </a:themeElements>
+  <a:objectDefaults/>
+  <a:extraClrSchemeLst/>
+  <a:extLst>
+    <a:ext uri="{05A4C25C-085E-4340-85A3-A5531E510DB2}">
+      <thm15:themeFamily xmlns:thm15="http://schemas.microsoft.com/office/thememl/2012/main" name="Office Theme" id="{62F939B6-93AF-4DB8-9C6B-D6C7DFDC589F}" vid="{4A3C46E8-61CC-4603-A589-7422A47A8E4A}"/>
+    </a:ext>
+  </a:extLst>
+</a:theme>
 </file>
</xml_diff>